<commit_message>
paper/talks: refresh CommsEE group-meeting PPT with split headline panels
Embed the new bishan_headline_panel_a.png / panel_b.png into the
22-slide Chinese group-meeting deck so the headline result renders at
its native aspect ratio on the slide instead of being stretched from
the combined PDF.

  paper/talks/paper9_v7_commsee_groupmeeting_zh.pptx  (986K -> 1.3M)
</commit_message>
<xml_diff>
--- a/paper/talks/paper9_v7_commsee_groupmeeting_zh.pptx
+++ b/paper/talks/paper9_v7_commsee_groupmeeting_zh.pptx
@@ -1996,6 +1996,18 @@
               <a:t>这是论文的 Fig. 1a，也是组会上最有展示价值的一张。横轴是 100 步规划进度，纵轴是当前坡度相对初始的下降百分点。粗蓝线是 5 个独立训练 ensemble 的均值轨迹，浅色带是 5 ep 包络。两条虚线分别是 Centralised PPO 和 Multi-Agent RL 院内基线。右侧 rail 给出头条数字 −1.289 ± 0.079%，对 PPO p=0.034 d=−1.90，对 MARL p&lt;10⁻⁴ d=−5.07，效应量都是 very large。口头补充：图上 −2.04% 和 −2.001% 是 regime B/C 的端点，属于另外两套 reconciliation，这页只 quote regime A 的 −1.289%——三个数字之间的关系下页详谈。</a:t>
             </a:r>
           </a:p>
+          <a:p>
+            <a:r>
+              <a:rPr sz="1100" b="0" i="1">
+                <a:solidFill>
+                  <a:srgbClr val="666666"/>
+                </a:solidFill>
+                <a:latin typeface="Microsoft YaHei"/>
+                <a:ea typeface="Microsoft YaHei"/>
+              </a:rPr>
+              <a:t>本页展示 headline figure 的 panel (a)（左半幅，逐步轨迹与 PPO/MARL 基线带）；panel (b) 的县域 swap 空间形态见 slide 9。</a:t>
+            </a:r>
+          </a:p>
         </p:txBody>
       </p:sp>
       <p:sp>
@@ -2148,6 +2160,18 @@
                 <a:ea typeface="Microsoft YaHei"/>
               </a:rPr>
               <a:t>右半幅 hero。讲两件事：一是 swap 总量小、动作集中——852 对 paired swap 在 5 万级地块里只占 ~1.6%；二是空间形态「贴着碎片边界走」，这跟县规划员手工拉图斑的直觉一致，是这套方法可被审批接受的重要属性。口头补充：如果听众里有 GIS 同事，可以指出红绿配对一一相等（426 对 426），这是 reward 设计里耕地总量守恒带来的硬约束，不是巧合。</a:t>
+            </a:r>
+          </a:p>
+          <a:p>
+            <a:r>
+              <a:rPr sz="1100" b="0" i="1">
+                <a:solidFill>
+                  <a:srgbClr val="666666"/>
+                </a:solidFill>
+                <a:latin typeface="Microsoft YaHei"/>
+                <a:ea typeface="Microsoft YaHei"/>
+              </a:rPr>
+              <a:t>本页展示 headline figure 的 panel (b)（县域 swap 空间形态）；panel (a) 的逐步轨迹与基线带见 slide 7。</a:t>
             </a:r>
           </a:p>
         </p:txBody>
@@ -10618,8 +10642,8 @@
         </p:nvCxnSpPr>
         <p:spPr>
           <a:xfrm>
-            <a:off x="2926080" y="2194560.0"/>
-            <a:ext cx="274320" cy="0.0"/>
+            <a:off x="2926080" y="2194560"/>
+            <a:ext cx="274320" cy="0"/>
           </a:xfrm>
           <a:prstGeom prst="line">
             <a:avLst/>
@@ -10852,8 +10876,8 @@
         </p:nvCxnSpPr>
         <p:spPr>
           <a:xfrm>
-            <a:off x="5623560" y="2194560.0"/>
-            <a:ext cx="274320" cy="0.0"/>
+            <a:off x="5623560" y="2194560"/>
+            <a:ext cx="274320" cy="0"/>
           </a:xfrm>
           <a:prstGeom prst="line">
             <a:avLst/>
@@ -11086,8 +11110,8 @@
         </p:nvCxnSpPr>
         <p:spPr>
           <a:xfrm>
-            <a:off x="8321040" y="2194560.0"/>
-            <a:ext cx="274320" cy="0.0"/>
+            <a:off x="8321040" y="2194560"/>
+            <a:ext cx="274320" cy="0"/>
           </a:xfrm>
           <a:prstGeom prst="line">
             <a:avLst/>
@@ -23055,41 +23079,49 @@
           </a:p>
         </p:txBody>
       </p:sp>
-      <p:cxnSp>
-        <p:nvCxnSpPr>
-          <p:cNvPr id="10" name="Connector 9"/>
-          <p:cNvCxnSpPr/>
-          <p:nvPr/>
-        </p:nvCxnSpPr>
-        <p:spPr>
-          <a:xfrm>
-            <a:off x="8869680.0" y="2331720"/>
-            <a:ext cx="0.0" cy="164592"/>
-          </a:xfrm>
-          <a:prstGeom prst="line">
-            <a:avLst/>
-          </a:prstGeom>
-          <a:ln w="15240">
-            <a:solidFill>
-              <a:srgbClr val="2E6FB0"/>
-            </a:solidFill>
+      <p:sp>
+        <p:nvSpPr>
+          <p:cNvPr id="10" name="DownArrow 9"/>
+          <p:cNvSpPr/>
+          <p:nvPr/>
+        </p:nvSpPr>
+        <p:spPr>
+          <a:xfrm>
+            <a:off x="8686800" y="2249424"/>
+            <a:ext cx="365760" cy="457200"/>
+          </a:xfrm>
+          <a:prstGeom prst="downArrow">
+            <a:avLst/>
+          </a:prstGeom>
+          <a:solidFill>
+            <a:srgbClr val="2E6FB0"/>
+          </a:solidFill>
+          <a:ln>
+            <a:noFill/>
           </a:ln>
         </p:spPr>
         <p:style>
-          <a:lnRef idx="2">
+          <a:lnRef idx="1">
             <a:schemeClr val="accent1"/>
           </a:lnRef>
-          <a:fillRef idx="0">
+          <a:fillRef idx="3">
             <a:schemeClr val="accent1"/>
           </a:fillRef>
-          <a:effectRef idx="1">
+          <a:effectRef idx="2">
             <a:schemeClr val="accent1"/>
           </a:effectRef>
           <a:fontRef idx="minor">
-            <a:schemeClr val="tx1"/>
+            <a:schemeClr val="lt1"/>
           </a:fontRef>
         </p:style>
-      </p:cxnSp>
+        <p:txBody>
+          <a:bodyPr rtlCol="0" anchor="ctr"/>
+          <a:lstStyle/>
+          <a:p>
+            <a:pPr algn="ctr"/>
+          </a:p>
+        </p:txBody>
+      </p:sp>
       <p:sp>
         <p:nvSpPr>
           <p:cNvPr id="11" name="Rectangle 10"/>
@@ -23098,7 +23130,7 @@
         </p:nvSpPr>
         <p:spPr>
           <a:xfrm>
-            <a:off x="6400800" y="2496312"/>
+            <a:off x="6400800" y="2624328"/>
             <a:ext cx="4937760" cy="502920"/>
           </a:xfrm>
           <a:prstGeom prst="rect">
@@ -23144,7 +23176,7 @@
         </p:nvSpPr>
         <p:spPr>
           <a:xfrm>
-            <a:off x="6537960" y="2532888"/>
+            <a:off x="6537960" y="2660904"/>
             <a:ext cx="4663440" cy="429768"/>
           </a:xfrm>
           <a:prstGeom prst="rect">
@@ -23196,41 +23228,49 @@
           </a:p>
         </p:txBody>
       </p:sp>
-      <p:cxnSp>
-        <p:nvCxnSpPr>
-          <p:cNvPr id="13" name="Connector 12"/>
-          <p:cNvCxnSpPr/>
-          <p:nvPr/>
-        </p:nvCxnSpPr>
-        <p:spPr>
-          <a:xfrm>
-            <a:off x="8869680.0" y="2999232"/>
-            <a:ext cx="0.0" cy="164592"/>
-          </a:xfrm>
-          <a:prstGeom prst="line">
-            <a:avLst/>
-          </a:prstGeom>
-          <a:ln w="15240">
-            <a:solidFill>
-              <a:srgbClr val="2E6FB0"/>
-            </a:solidFill>
+      <p:sp>
+        <p:nvSpPr>
+          <p:cNvPr id="13" name="DownArrow 12"/>
+          <p:cNvSpPr/>
+          <p:nvPr/>
+        </p:nvSpPr>
+        <p:spPr>
+          <a:xfrm>
+            <a:off x="8686800" y="3044952"/>
+            <a:ext cx="365760" cy="457200"/>
+          </a:xfrm>
+          <a:prstGeom prst="downArrow">
+            <a:avLst/>
+          </a:prstGeom>
+          <a:solidFill>
+            <a:srgbClr val="2E6FB0"/>
+          </a:solidFill>
+          <a:ln>
+            <a:noFill/>
           </a:ln>
         </p:spPr>
         <p:style>
-          <a:lnRef idx="2">
+          <a:lnRef idx="1">
             <a:schemeClr val="accent1"/>
           </a:lnRef>
-          <a:fillRef idx="0">
+          <a:fillRef idx="3">
             <a:schemeClr val="accent1"/>
           </a:fillRef>
-          <a:effectRef idx="1">
+          <a:effectRef idx="2">
             <a:schemeClr val="accent1"/>
           </a:effectRef>
           <a:fontRef idx="minor">
-            <a:schemeClr val="tx1"/>
+            <a:schemeClr val="lt1"/>
           </a:fontRef>
         </p:style>
-      </p:cxnSp>
+        <p:txBody>
+          <a:bodyPr rtlCol="0" anchor="ctr"/>
+          <a:lstStyle/>
+          <a:p>
+            <a:pPr algn="ctr"/>
+          </a:p>
+        </p:txBody>
+      </p:sp>
       <p:sp>
         <p:nvSpPr>
           <p:cNvPr id="14" name="Rectangle 13"/>
@@ -23239,7 +23279,7 @@
         </p:nvSpPr>
         <p:spPr>
           <a:xfrm>
-            <a:off x="6400800" y="3163824"/>
+            <a:off x="6400800" y="3419856"/>
             <a:ext cx="4937760" cy="502920"/>
           </a:xfrm>
           <a:prstGeom prst="rect">
@@ -23285,7 +23325,7 @@
         </p:nvSpPr>
         <p:spPr>
           <a:xfrm>
-            <a:off x="6537960" y="3200400"/>
+            <a:off x="6537960" y="3456432"/>
             <a:ext cx="4663440" cy="429768"/>
           </a:xfrm>
           <a:prstGeom prst="rect">
@@ -23337,41 +23377,49 @@
           </a:p>
         </p:txBody>
       </p:sp>
-      <p:cxnSp>
-        <p:nvCxnSpPr>
-          <p:cNvPr id="16" name="Connector 15"/>
-          <p:cNvCxnSpPr/>
-          <p:nvPr/>
-        </p:nvCxnSpPr>
-        <p:spPr>
-          <a:xfrm>
-            <a:off x="8869680.0" y="3666744"/>
-            <a:ext cx="0.0" cy="164592"/>
-          </a:xfrm>
-          <a:prstGeom prst="line">
-            <a:avLst/>
-          </a:prstGeom>
-          <a:ln w="15240">
-            <a:solidFill>
-              <a:srgbClr val="2E6FB0"/>
-            </a:solidFill>
+      <p:sp>
+        <p:nvSpPr>
+          <p:cNvPr id="16" name="DownArrow 15"/>
+          <p:cNvSpPr/>
+          <p:nvPr/>
+        </p:nvSpPr>
+        <p:spPr>
+          <a:xfrm>
+            <a:off x="8686800" y="3840480"/>
+            <a:ext cx="365760" cy="457200"/>
+          </a:xfrm>
+          <a:prstGeom prst="downArrow">
+            <a:avLst/>
+          </a:prstGeom>
+          <a:solidFill>
+            <a:srgbClr val="2E6FB0"/>
+          </a:solidFill>
+          <a:ln>
+            <a:noFill/>
           </a:ln>
         </p:spPr>
         <p:style>
-          <a:lnRef idx="2">
+          <a:lnRef idx="1">
             <a:schemeClr val="accent1"/>
           </a:lnRef>
-          <a:fillRef idx="0">
+          <a:fillRef idx="3">
             <a:schemeClr val="accent1"/>
           </a:fillRef>
-          <a:effectRef idx="1">
+          <a:effectRef idx="2">
             <a:schemeClr val="accent1"/>
           </a:effectRef>
           <a:fontRef idx="minor">
-            <a:schemeClr val="tx1"/>
+            <a:schemeClr val="lt1"/>
           </a:fontRef>
         </p:style>
-      </p:cxnSp>
+        <p:txBody>
+          <a:bodyPr rtlCol="0" anchor="ctr"/>
+          <a:lstStyle/>
+          <a:p>
+            <a:pPr algn="ctr"/>
+          </a:p>
+        </p:txBody>
+      </p:sp>
       <p:sp>
         <p:nvSpPr>
           <p:cNvPr id="17" name="Rectangle 16"/>
@@ -23380,7 +23428,7 @@
         </p:nvSpPr>
         <p:spPr>
           <a:xfrm>
-            <a:off x="6400800" y="3831336"/>
+            <a:off x="6400800" y="4215384"/>
             <a:ext cx="4937760" cy="502920"/>
           </a:xfrm>
           <a:prstGeom prst="rect">
@@ -23426,7 +23474,7 @@
         </p:nvSpPr>
         <p:spPr>
           <a:xfrm>
-            <a:off x="6537960" y="3867912"/>
+            <a:off x="6537960" y="4251960"/>
             <a:ext cx="4663440" cy="429768"/>
           </a:xfrm>
           <a:prstGeom prst="rect">
@@ -23478,41 +23526,49 @@
           </a:p>
         </p:txBody>
       </p:sp>
-      <p:cxnSp>
-        <p:nvCxnSpPr>
-          <p:cNvPr id="19" name="Connector 18"/>
-          <p:cNvCxnSpPr/>
-          <p:nvPr/>
-        </p:nvCxnSpPr>
-        <p:spPr>
-          <a:xfrm>
-            <a:off x="8869680.0" y="4334256"/>
-            <a:ext cx="0.0" cy="164592"/>
-          </a:xfrm>
-          <a:prstGeom prst="line">
-            <a:avLst/>
-          </a:prstGeom>
-          <a:ln w="15240">
-            <a:solidFill>
-              <a:srgbClr val="2E6FB0"/>
-            </a:solidFill>
+      <p:sp>
+        <p:nvSpPr>
+          <p:cNvPr id="19" name="DownArrow 18"/>
+          <p:cNvSpPr/>
+          <p:nvPr/>
+        </p:nvSpPr>
+        <p:spPr>
+          <a:xfrm>
+            <a:off x="8686800" y="4636008"/>
+            <a:ext cx="365760" cy="457200"/>
+          </a:xfrm>
+          <a:prstGeom prst="downArrow">
+            <a:avLst/>
+          </a:prstGeom>
+          <a:solidFill>
+            <a:srgbClr val="2E6FB0"/>
+          </a:solidFill>
+          <a:ln>
+            <a:noFill/>
           </a:ln>
         </p:spPr>
         <p:style>
-          <a:lnRef idx="2">
+          <a:lnRef idx="1">
             <a:schemeClr val="accent1"/>
           </a:lnRef>
-          <a:fillRef idx="0">
+          <a:fillRef idx="3">
             <a:schemeClr val="accent1"/>
           </a:fillRef>
-          <a:effectRef idx="1">
+          <a:effectRef idx="2">
             <a:schemeClr val="accent1"/>
           </a:effectRef>
           <a:fontRef idx="minor">
-            <a:schemeClr val="tx1"/>
+            <a:schemeClr val="lt1"/>
           </a:fontRef>
         </p:style>
-      </p:cxnSp>
+        <p:txBody>
+          <a:bodyPr rtlCol="0" anchor="ctr"/>
+          <a:lstStyle/>
+          <a:p>
+            <a:pPr algn="ctr"/>
+          </a:p>
+        </p:txBody>
+      </p:sp>
       <p:sp>
         <p:nvSpPr>
           <p:cNvPr id="20" name="Rectangle 19"/>
@@ -23521,7 +23577,7 @@
         </p:nvSpPr>
         <p:spPr>
           <a:xfrm>
-            <a:off x="6400800" y="4498848"/>
+            <a:off x="6400800" y="5010912"/>
             <a:ext cx="4937760" cy="502920"/>
           </a:xfrm>
           <a:prstGeom prst="rect">
@@ -23567,7 +23623,7 @@
         </p:nvSpPr>
         <p:spPr>
           <a:xfrm>
-            <a:off x="6537960" y="4535424"/>
+            <a:off x="6537960" y="5047488"/>
             <a:ext cx="4663440" cy="429768"/>
           </a:xfrm>
           <a:prstGeom prst="rect">
@@ -23627,8 +23683,8 @@
         </p:nvCxnSpPr>
         <p:spPr>
           <a:xfrm flipH="1">
-            <a:off x="6035040" y="4750308.0"/>
-            <a:ext cx="365760" cy="0.0"/>
+            <a:off x="6035040" y="5262372"/>
+            <a:ext cx="365760" cy="0"/>
           </a:xfrm>
           <a:prstGeom prst="line">
             <a:avLst/>
@@ -24743,7 +24799,7 @@
       </p:cxnSp>
       <p:pic>
         <p:nvPicPr>
-          <p:cNvPr id="5" name="Picture 4" descr="bishan_traj.png"/>
+          <p:cNvPr id="5" name="Picture 4" descr="bishan_headline_panel_a.png"/>
           <p:cNvPicPr>
             <a:picLocks noChangeAspect="1"/>
           </p:cNvPicPr>
@@ -24757,8 +24813,8 @@
         </p:blipFill>
         <p:spPr>
           <a:xfrm>
-            <a:off x="502920" y="1376011"/>
-            <a:ext cx="7680960" cy="4197418"/>
+            <a:off x="502920" y="1280160"/>
+            <a:ext cx="7269480" cy="4974336"/>
           </a:xfrm>
           <a:prstGeom prst="rect">
             <a:avLst/>
@@ -26889,7 +26945,7 @@
       </p:cxnSp>
       <p:pic>
         <p:nvPicPr>
-          <p:cNvPr id="5" name="Picture 4" descr="bishan_swap.png"/>
+          <p:cNvPr id="5" name="Picture 4" descr="bishan_headline_panel_b.png"/>
           <p:cNvPicPr>
             <a:picLocks noChangeAspect="1"/>
           </p:cNvPicPr>
@@ -26903,8 +26959,8 @@
         </p:blipFill>
         <p:spPr>
           <a:xfrm>
-            <a:off x="1168936" y="1188720"/>
-            <a:ext cx="4611568" cy="4754880"/>
+            <a:off x="2606040" y="1097280"/>
+            <a:ext cx="2295144" cy="4846320"/>
           </a:xfrm>
           <a:prstGeom prst="rect">
             <a:avLst/>

</xml_diff>